<commit_message>
Notas del orador: reparto de la parte de YOLO entre los dos expositores
Co-Authored-By: Claude Sonnet 5.5 <noreply@anthropic.com>
Claude-Session: https://claude.ai/code/session_01DEf93YX9buq9WP7xjfm3a8
</commit_message>
<xml_diff>
--- a/docs/presentacion/PrintWatch_YOLO11.pptx
+++ b/docs/presentacion/PrintWatch_YOLO11.pptx
@@ -112,18 +112,18 @@
   <p:extLst>
     <p:ext uri="{521415D9-36F7-43E2-AB2F-B90AF26B5E84}">
       <p14:sectionLst xmlns:p14="http://schemas.microsoft.com/office/powerpoint/2010/main">
-        <p14:section name="Portada" id="{284843d3-4642-467f-cde3-24282e9f1e83}">
+        <p14:section name="Portada" id="{014115c3-5c72-2463-dc59-ee7e47550ec5}">
           <p14:sldIdLst>
             <p14:sldId id="256"/>
           </p14:sldIdLst>
         </p14:section>
-        <p14:section name="Modelo YOLO11s" id="{b79d263f-57d7-e36e-d5e4-b425a00a0432}">
+        <p14:section name="Modelo YOLO11s" id="{74a1c044-b619-22ac-9364-56a6699425d3}">
           <p14:sldIdLst>
             <p14:sldId id="257"/>
             <p14:sldId id="258"/>
           </p14:sldIdLst>
         </p14:section>
-        <p14:section name="Datos y entrenamiento" id="{d024e762-a8d1-dd1e-0917-9a66c5b25a6f}">
+        <p14:section name="Datos y entrenamiento" id="{61f5033a-835c-4cb5-78f9-24ba7a507c3b}">
           <p14:sldIdLst>
             <p14:sldId id="259"/>
             <p14:sldId id="260"/>
@@ -2421,7 +2421,7 @@
           <a:p>
             <a:r>
               <a:rPr lang="en-US" dirty="0"/>
-              <a:t>Continuación de la parte de mi compañero: el tensor (1, 3, 640, 640) ya normalizado es lo que entra a la red. YOLO es un detector de una sola etapa: la misma pasada hacia adelante localiza y clasifica. La imagen se reparte en celdas en tres escalas, cada celda propone una caja y probabilidades de clase, y el NMS limpia los duplicados.</a:t>
+              <a:t>El tensor (1, 3, 640, 640) ya normalizado es lo que entra a la red. YOLO es un detector de una sola etapa: la misma pasada hacia adelante localiza y clasifica. La imagen se reparte en celdas en tres escalas, cada celda propone una caja y probabilidades de clase, y el NMS limpia los duplicados.</a:t>
             </a:r>
             <a:endParaRPr lang="en-US" dirty="0"/>
           </a:p>
@@ -2597,7 +2597,7 @@
           <a:p>
             <a:r>
               <a:rPr lang="en-US" dirty="0"/>
-              <a:t>Combinamos tres datasets públicos de Roboflow Universe: 3612, 1002 y 999 imágenes, 5613 en total, mapeados a nuestras seis clases. Dividimos 70, 15 y 15 por ciento por secuencia de video y no por fotograma, porque frames consecutivos son casi idénticos y, si quedaran repartidos entre entrenamiento y prueba, las métricas saldrían infladas: eso es data leakage. El conjunto de prueba real quedó en 841 imágenes porque la división por secuencia no es exacta.</a:t>
+              <a:t>Aquí cambia el expositor: se pasa de cómo funciona YOLO a cómo se entrenó. Combinamos tres datasets públicos de Roboflow Universe: 3612, 1002 y 999 imágenes, 5613 en total, mapeados a nuestras seis clases. Dividimos 70, 15 y 15 por ciento por secuencia de video y no por fotograma, porque frames consecutivos son casi idénticos y, si quedaran repartidos entre entrenamiento y prueba, las métricas saldrían infladas: eso es data leakage. El conjunto de prueba real quedó en 841 imágenes porque la división por secuencia no es exacta.</a:t>
             </a:r>
             <a:endParaRPr lang="en-US" dirty="0"/>
           </a:p>

</xml_diff>